<commit_message>
M01-W05-L01 분량 기준 보강
원심분리 두 방식의 구분, 태그 기반 형광 표지, 이온 기울기가 신호의
재료로 재사용된다는 점을 덧붙여 22,000자 기준을 넘긴다.

Co-Authored-By: Claude Opus 5 <noreply@anthropic.com>
Claude-Session: https://claude.ai/code/session_01TGVgH4PG4LB6Jq8r4MtGjs
</commit_message>
<xml_diff>
--- a/curriculum/M01/W05/L01/slides-2.pptx
+++ b/curriculum/M01/W05/L01/slides-2.pptx
@@ -6467,7 +6467,7 @@
               </a:spcAft>
             </a:pPr>
             <a:r>
-              <a:rPr sz="1600" b="1" i="0">
+              <a:rPr sz="1400" b="1" i="0">
                 <a:solidFill>
                   <a:srgbClr val="F2B705"/>
                 </a:solidFill>
@@ -6478,7 +6478,7 @@
               <a:t>•  </a:t>
             </a:r>
             <a:r>
-              <a:rPr sz="1600" b="1" i="0">
+              <a:rPr sz="1400" b="1" i="0">
                 <a:solidFill>
                   <a:srgbClr val="11202B"/>
                 </a:solidFill>
@@ -6489,7 +6489,7 @@
               <a:t>형광 현미경</a:t>
             </a:r>
             <a:r>
-              <a:rPr sz="1600" b="0" i="0">
+              <a:rPr sz="1400" b="0" i="0">
                 <a:solidFill>
                   <a:srgbClr val="11202B"/>
                 </a:solidFill>
@@ -6500,7 +6500,7 @@
               <a:t>이 현대 세포생물학의 중심 도구다. 형광 분자는 특정 파장의 빛을 흡수하고 더 긴 파장의 빛을 내므로, 여기 광과 방출 광을 필터로 분리하면 표지된 분자만 밝게 보인다. 표지 방법은 두 가지다. 항체에 형광색소를 붙여 고정한 세포를 염색하는 </a:t>
             </a:r>
             <a:r>
-              <a:rPr sz="1600" b="1" i="0">
+              <a:rPr sz="1400" b="1" i="0">
                 <a:solidFill>
                   <a:srgbClr val="11202B"/>
                 </a:solidFill>
@@ -6511,7 +6511,7 @@
               <a:t>immunofluorescence</a:t>
             </a:r>
             <a:r>
-              <a:rPr sz="1600" b="0" i="0">
+              <a:rPr sz="1400" b="0" i="0">
                 <a:solidFill>
                   <a:srgbClr val="11202B"/>
                 </a:solidFill>
@@ -6522,7 +6522,7 @@
               <a:t>, 그리고 관심 단백질의 유전자에 </a:t>
             </a:r>
             <a:r>
-              <a:rPr sz="1600" b="1" i="0">
+              <a:rPr sz="1400" b="1" i="0">
                 <a:solidFill>
                   <a:srgbClr val="11202B"/>
                 </a:solidFill>
@@ -6533,7 +6533,7 @@
               <a:t>green fluorescent protein(GFP)</a:t>
             </a:r>
             <a:r>
-              <a:rPr sz="1600" b="0" i="0">
+              <a:rPr sz="1400" b="0" i="0">
                 <a:solidFill>
                   <a:srgbClr val="11202B"/>
                 </a:solidFill>
@@ -6551,7 +6551,7 @@
               </a:spcAft>
             </a:pPr>
             <a:r>
-              <a:rPr sz="1600" b="1" i="0">
+              <a:rPr sz="1400" b="1" i="0">
                 <a:solidFill>
                   <a:srgbClr val="F2B705"/>
                 </a:solidFill>
@@ -6562,7 +6562,7 @@
               <a:t>•  </a:t>
             </a:r>
             <a:r>
-              <a:rPr sz="1600" b="1" i="0">
+              <a:rPr sz="1400" b="0" i="0">
                 <a:solidFill>
                   <a:srgbClr val="11202B"/>
                 </a:solidFill>
@@ -6570,10 +6570,39 @@
                 <a:ea typeface="Malgun Gothic"/>
                 <a:cs typeface="Malgun Gothic"/>
               </a:rPr>
+              <a:t>세 번째 표지 방법도 널리 쓰인다. 작은 태그 서열을 붙여 두고 그 태그에 결합하는 형광 분자를 나중에 넣는 방식이다. 형광 단백질보다 크기가 작아 표적 단백질의 기능을 덜 방해하고, 원하는 시점에만 표지할 수 있다.</a:t>
+            </a:r>
+          </a:p>
+          <a:p>
+            <a:pPr>
+              <a:spcAft>
+                <a:spcPts val="900"/>
+              </a:spcAft>
+            </a:pPr>
+            <a:r>
+              <a:rPr sz="1400" b="1" i="0">
+                <a:solidFill>
+                  <a:srgbClr val="F2B705"/>
+                </a:solidFill>
+                <a:latin typeface="Malgun Gothic"/>
+                <a:ea typeface="Malgun Gothic"/>
+                <a:cs typeface="Malgun Gothic"/>
+              </a:rPr>
+              <a:t>•  </a:t>
+            </a:r>
+            <a:r>
+              <a:rPr sz="1400" b="1" i="0">
+                <a:solidFill>
+                  <a:srgbClr val="11202B"/>
+                </a:solidFill>
+                <a:latin typeface="Malgun Gothic"/>
+                <a:ea typeface="Malgun Gothic"/>
+                <a:cs typeface="Malgun Gothic"/>
+              </a:rPr>
               <a:t>전자 현미경</a:t>
             </a:r>
             <a:r>
-              <a:rPr sz="1600" b="0" i="0">
+              <a:rPr sz="1400" b="0" i="0">
                 <a:solidFill>
                   <a:srgbClr val="11202B"/>
                 </a:solidFill>
@@ -7575,6 +7604,17 @@
               <a:t>•  </a:t>
             </a:r>
             <a:r>
+              <a:rPr sz="1400" b="0" i="0">
+                <a:solidFill>
+                  <a:srgbClr val="11202B"/>
+                </a:solidFill>
+                <a:latin typeface="Malgun Gothic"/>
+                <a:ea typeface="Malgun Gothic"/>
+                <a:cs typeface="Malgun Gothic"/>
+              </a:rPr>
+              <a:t>두 방식을 구분해야 한다. </a:t>
+            </a:r>
+            <a:r>
               <a:rPr sz="1400" b="1" i="0">
                 <a:solidFill>
                   <a:srgbClr val="11202B"/>
@@ -7594,7 +7634,29 @@
                 <a:ea typeface="Malgun Gothic"/>
                 <a:cs typeface="Malgun Gothic"/>
               </a:rPr>
-              <a:t>는 회전 속도를 단계적으로 올리며 침전물을 차례로 얻는다.</a:t>
+              <a:t>는 회전 속도를 단계적으로 올리며 침전물을 차례로 얻는다. 주로 크기에 따라 갈리므로 크기가 비슷한 소기관은 섞인다. </a:t>
+            </a:r>
+            <a:r>
+              <a:rPr sz="1400" b="1" i="0">
+                <a:solidFill>
+                  <a:srgbClr val="11202B"/>
+                </a:solidFill>
+                <a:latin typeface="Malgun Gothic"/>
+                <a:ea typeface="Malgun Gothic"/>
+                <a:cs typeface="Malgun Gothic"/>
+              </a:rPr>
+              <a:t>밀도구배 원심분리</a:t>
+            </a:r>
+            <a:r>
+              <a:rPr sz="1400" b="0" i="0">
+                <a:solidFill>
+                  <a:srgbClr val="11202B"/>
+                </a:solidFill>
+                <a:latin typeface="Malgun Gothic"/>
+                <a:ea typeface="Malgun Gothic"/>
+                <a:cs typeface="Malgun Gothic"/>
+              </a:rPr>
+              <a:t>는 설탕이나 Percoll로 밀도가 점점 높아지는 층을 만들고 그 위에서 돌린다. 입자가 자기 밀도와 같은 위치에서 멈추므로 크기가 비슷해도 밀도가 다르면 분리된다. 크기로 갈리지 않는 것을 밀도로 가르는 것이며, 두 방법을 순서대로 쓰는 것이 보통이다.</a:t>
             </a:r>
           </a:p>
         </p:txBody>

</xml_diff>